<commit_message>
Diagrama de arquitectura modificado
</commit_message>
<xml_diff>
--- a/DOCS/Arquitectura.pptx
+++ b/DOCS/Arquitectura.pptx
@@ -268,7 +268,7 @@
           <a:p>
             <a:fld id="{3D5740FC-690B-D347-93A9-D60E805DA9D3}" type="datetimeFigureOut">
               <a:rPr lang="es-ES" smtClean="0"/>
-              <a:t>26/12/25</a:t>
+              <a:t>12/1/26</a:t>
             </a:fld>
             <a:endParaRPr lang="es-ES"/>
           </a:p>
@@ -466,7 +466,7 @@
           <a:p>
             <a:fld id="{3D5740FC-690B-D347-93A9-D60E805DA9D3}" type="datetimeFigureOut">
               <a:rPr lang="es-ES" smtClean="0"/>
-              <a:t>26/12/25</a:t>
+              <a:t>12/1/26</a:t>
             </a:fld>
             <a:endParaRPr lang="es-ES"/>
           </a:p>
@@ -674,7 +674,7 @@
           <a:p>
             <a:fld id="{3D5740FC-690B-D347-93A9-D60E805DA9D3}" type="datetimeFigureOut">
               <a:rPr lang="es-ES" smtClean="0"/>
-              <a:t>26/12/25</a:t>
+              <a:t>12/1/26</a:t>
             </a:fld>
             <a:endParaRPr lang="es-ES"/>
           </a:p>
@@ -872,7 +872,7 @@
           <a:p>
             <a:fld id="{3D5740FC-690B-D347-93A9-D60E805DA9D3}" type="datetimeFigureOut">
               <a:rPr lang="es-ES" smtClean="0"/>
-              <a:t>26/12/25</a:t>
+              <a:t>12/1/26</a:t>
             </a:fld>
             <a:endParaRPr lang="es-ES"/>
           </a:p>
@@ -1147,7 +1147,7 @@
           <a:p>
             <a:fld id="{3D5740FC-690B-D347-93A9-D60E805DA9D3}" type="datetimeFigureOut">
               <a:rPr lang="es-ES" smtClean="0"/>
-              <a:t>26/12/25</a:t>
+              <a:t>12/1/26</a:t>
             </a:fld>
             <a:endParaRPr lang="es-ES"/>
           </a:p>
@@ -1412,7 +1412,7 @@
           <a:p>
             <a:fld id="{3D5740FC-690B-D347-93A9-D60E805DA9D3}" type="datetimeFigureOut">
               <a:rPr lang="es-ES" smtClean="0"/>
-              <a:t>26/12/25</a:t>
+              <a:t>12/1/26</a:t>
             </a:fld>
             <a:endParaRPr lang="es-ES"/>
           </a:p>
@@ -1824,7 +1824,7 @@
           <a:p>
             <a:fld id="{3D5740FC-690B-D347-93A9-D60E805DA9D3}" type="datetimeFigureOut">
               <a:rPr lang="es-ES" smtClean="0"/>
-              <a:t>26/12/25</a:t>
+              <a:t>12/1/26</a:t>
             </a:fld>
             <a:endParaRPr lang="es-ES"/>
           </a:p>
@@ -1965,7 +1965,7 @@
           <a:p>
             <a:fld id="{3D5740FC-690B-D347-93A9-D60E805DA9D3}" type="datetimeFigureOut">
               <a:rPr lang="es-ES" smtClean="0"/>
-              <a:t>26/12/25</a:t>
+              <a:t>12/1/26</a:t>
             </a:fld>
             <a:endParaRPr lang="es-ES"/>
           </a:p>
@@ -2078,7 +2078,7 @@
           <a:p>
             <a:fld id="{3D5740FC-690B-D347-93A9-D60E805DA9D3}" type="datetimeFigureOut">
               <a:rPr lang="es-ES" smtClean="0"/>
-              <a:t>26/12/25</a:t>
+              <a:t>12/1/26</a:t>
             </a:fld>
             <a:endParaRPr lang="es-ES"/>
           </a:p>
@@ -2389,7 +2389,7 @@
           <a:p>
             <a:fld id="{3D5740FC-690B-D347-93A9-D60E805DA9D3}" type="datetimeFigureOut">
               <a:rPr lang="es-ES" smtClean="0"/>
-              <a:t>26/12/25</a:t>
+              <a:t>12/1/26</a:t>
             </a:fld>
             <a:endParaRPr lang="es-ES"/>
           </a:p>
@@ -2677,7 +2677,7 @@
           <a:p>
             <a:fld id="{3D5740FC-690B-D347-93A9-D60E805DA9D3}" type="datetimeFigureOut">
               <a:rPr lang="es-ES" smtClean="0"/>
-              <a:t>26/12/25</a:t>
+              <a:t>12/1/26</a:t>
             </a:fld>
             <a:endParaRPr lang="es-ES"/>
           </a:p>
@@ -2918,7 +2918,7 @@
           <a:p>
             <a:fld id="{3D5740FC-690B-D347-93A9-D60E805DA9D3}" type="datetimeFigureOut">
               <a:rPr lang="es-ES" smtClean="0"/>
-              <a:t>26/12/25</a:t>
+              <a:t>12/1/26</a:t>
             </a:fld>
             <a:endParaRPr lang="es-ES"/>
           </a:p>
@@ -3337,10 +3337,10 @@
       </p:grpSpPr>
       <p:pic>
         <p:nvPicPr>
-          <p:cNvPr id="5" name="Gráfico 4">
-            <a:extLst>
-              <a:ext uri="{FF2B5EF4-FFF2-40B4-BE49-F238E27FC236}">
-                <a16:creationId xmlns:a16="http://schemas.microsoft.com/office/drawing/2014/main" id="{30EB5B13-D8D4-1E51-CB28-9245854C1D09}"/>
+          <p:cNvPr id="2" name="Imagen 1">
+            <a:extLst>
+              <a:ext uri="{FF2B5EF4-FFF2-40B4-BE49-F238E27FC236}">
+                <a16:creationId xmlns:a16="http://schemas.microsoft.com/office/drawing/2014/main" id="{439F11E1-5C87-9A93-3286-1B5475D03235}"/>
               </a:ext>
             </a:extLst>
           </p:cNvPr>
@@ -3350,21 +3350,15 @@
           <p:nvPr/>
         </p:nvPicPr>
         <p:blipFill>
-          <a:blip r:embed="rId2">
-            <a:extLst>
-              <a:ext uri="{96DAC541-7B7A-43D3-8B79-37D633B846F1}">
-                <asvg:svgBlip xmlns:asvg="http://schemas.microsoft.com/office/drawing/2016/SVG/main" r:embed="rId3"/>
-              </a:ext>
-            </a:extLst>
-          </a:blip>
+          <a:blip r:embed="rId2"/>
           <a:stretch>
             <a:fillRect/>
           </a:stretch>
         </p:blipFill>
         <p:spPr>
           <a:xfrm>
-            <a:off x="171451" y="1"/>
-            <a:ext cx="12020550" cy="6858000"/>
+            <a:off x="267557" y="873452"/>
+            <a:ext cx="11656886" cy="5111096"/>
           </a:xfrm>
           <a:prstGeom prst="rect">
             <a:avLst/>

</xml_diff>